<commit_message>
docs: update team members in Report and Presentation (Narne Adithya Hanuman, G Sreemanth, V. Umika)
</commit_message>
<xml_diff>
--- a/docs/DNS Client Application.pptx
+++ b/docs/DNS Client Application.pptx
@@ -1903,7 +1903,7 @@
                   </a:schemeClr>
                 </a:solidFill>
               </a:rPr>
-              <a:t>V.ROHITH                  KOPPARTHI PUJITH SAI RAMAN</a:t>
+              <a:t>Narne Adithya Hanuman  |  G Sreemanth  |  V. Umika</a:t>
             </a:r>
           </a:p>
           <a:p>
@@ -1915,7 +1915,7 @@
                   </a:schemeClr>
                 </a:solidFill>
               </a:rPr>
-              <a:t>24BCI0245                         24BCI0198</a:t>
+              <a:t>Slot: F1  |  Team: Team 13</a:t>
             </a:r>
           </a:p>
         </p:txBody>

</xml_diff>